<commit_message>
feat(group-meeting): add git versioning guide and QA gates for deck quality
- Document per-session git workflow for PPT iteration in SKILL.md
- Add bold ratio, textbox count, and overlap checks to qa_deck.sh
- Update group meeting template

Co-Authored-By: Claude Haiku 4.5 <noreply@anthropic.com>
</commit_message>
<xml_diff>
--- a/.agents/skills/group-meeting/ppt/组会模版.pptx
+++ b/.agents/skills/group-meeting/ppt/组会模版.pptx
@@ -19375,7 +19375,7 @@
         <p:spPr>
           <a:xfrm>
             <a:off x="1838696" y="154379"/>
-            <a:ext cx="5029200" cy="523220"/>
+            <a:ext cx="9000000" cy="523220"/>
           </a:xfrm>
           <a:prstGeom prst="rect">
             <a:avLst/>
@@ -19383,7 +19383,7 @@
           <a:noFill/>
         </p:spPr>
         <p:txBody>
-          <a:bodyPr wrap="square" rtlCol="0">
+          <a:bodyPr wrap="none" rtlCol="0">
             <a:spAutoFit/>
           </a:bodyPr>
           <a:lstStyle/>
@@ -21361,7 +21361,7 @@
 </file>
 
 <file path=ppt/theme/theme6.xml><?xml version="1.0" encoding="utf-8"?>
-<a:theme xmlns:a="http://schemas.openxmlformats.org/drawingml/2006/main" name="1_Office Theme">
+<a:theme xmlns:thm15="http://schemas.microsoft.com/office/thememl/2012/main" xmlns:a="http://schemas.openxmlformats.org/drawingml/2006/main" name="1_Office Theme">
   <a:themeElements>
     <a:clrScheme name="Office">
       <a:dk1>

</xml_diff>